<commit_message>
A minor explanation added ROI
</commit_message>
<xml_diff>
--- a/reports/Capstone_Presentation.pptx
+++ b/reports/Capstone_Presentation.pptx
@@ -4594,7 +4594,7 @@
           <a:p>
             <a:fld id="{1C517A45-943C-42E3-AA2A-6F37792D039D}" type="datetimeFigureOut">
               <a:rPr lang="en-US" smtClean="0"/>
-              <a:t>07-Mar-25</a:t>
+              <a:t>09-Mar-25</a:t>
             </a:fld>
             <a:endParaRPr lang="en-US"/>
           </a:p>
@@ -4932,7 +4932,7 @@
           <a:p>
             <a:fld id="{1C517A45-943C-42E3-AA2A-6F37792D039D}" type="datetimeFigureOut">
               <a:rPr lang="en-US" smtClean="0"/>
-              <a:t>07-Mar-25</a:t>
+              <a:t>09-Mar-25</a:t>
             </a:fld>
             <a:endParaRPr lang="en-US"/>
           </a:p>
@@ -5333,7 +5333,7 @@
           <a:p>
             <a:fld id="{1C517A45-943C-42E3-AA2A-6F37792D039D}" type="datetimeFigureOut">
               <a:rPr lang="en-US" smtClean="0"/>
-              <a:t>07-Mar-25</a:t>
+              <a:t>09-Mar-25</a:t>
             </a:fld>
             <a:endParaRPr lang="en-US"/>
           </a:p>
@@ -5669,7 +5669,7 @@
           <a:p>
             <a:fld id="{1C517A45-943C-42E3-AA2A-6F37792D039D}" type="datetimeFigureOut">
               <a:rPr lang="en-US" smtClean="0"/>
-              <a:t>07-Mar-25</a:t>
+              <a:t>09-Mar-25</a:t>
             </a:fld>
             <a:endParaRPr lang="en-US"/>
           </a:p>
@@ -5989,7 +5989,7 @@
           <a:p>
             <a:fld id="{1C517A45-943C-42E3-AA2A-6F37792D039D}" type="datetimeFigureOut">
               <a:rPr lang="en-US" smtClean="0"/>
-              <a:t>07-Mar-25</a:t>
+              <a:t>09-Mar-25</a:t>
             </a:fld>
             <a:endParaRPr lang="en-US"/>
           </a:p>
@@ -6385,7 +6385,7 @@
           <a:p>
             <a:fld id="{1C517A45-943C-42E3-AA2A-6F37792D039D}" type="datetimeFigureOut">
               <a:rPr lang="en-US" smtClean="0"/>
-              <a:t>07-Mar-25</a:t>
+              <a:t>09-Mar-25</a:t>
             </a:fld>
             <a:endParaRPr lang="en-US"/>
           </a:p>
@@ -6642,7 +6642,7 @@
           <a:p>
             <a:fld id="{1C517A45-943C-42E3-AA2A-6F37792D039D}" type="datetimeFigureOut">
               <a:rPr lang="en-US" smtClean="0"/>
-              <a:t>07-Mar-25</a:t>
+              <a:t>09-Mar-25</a:t>
             </a:fld>
             <a:endParaRPr lang="en-US"/>
           </a:p>
@@ -6904,7 +6904,7 @@
           <a:p>
             <a:fld id="{1C517A45-943C-42E3-AA2A-6F37792D039D}" type="datetimeFigureOut">
               <a:rPr lang="en-US" smtClean="0"/>
-              <a:t>07-Mar-25</a:t>
+              <a:t>09-Mar-25</a:t>
             </a:fld>
             <a:endParaRPr lang="en-US"/>
           </a:p>
@@ -7166,7 +7166,7 @@
           <a:p>
             <a:fld id="{1C517A45-943C-42E3-AA2A-6F37792D039D}" type="datetimeFigureOut">
               <a:rPr lang="en-US" smtClean="0"/>
-              <a:t>07-Mar-25</a:t>
+              <a:t>09-Mar-25</a:t>
             </a:fld>
             <a:endParaRPr lang="en-US"/>
           </a:p>
@@ -7495,7 +7495,7 @@
           <a:p>
             <a:fld id="{1C517A45-943C-42E3-AA2A-6F37792D039D}" type="datetimeFigureOut">
               <a:rPr lang="en-US" smtClean="0"/>
-              <a:t>07-Mar-25</a:t>
+              <a:t>09-Mar-25</a:t>
             </a:fld>
             <a:endParaRPr lang="en-US"/>
           </a:p>
@@ -7818,7 +7818,7 @@
           <a:p>
             <a:fld id="{1C517A45-943C-42E3-AA2A-6F37792D039D}" type="datetimeFigureOut">
               <a:rPr lang="en-US" smtClean="0"/>
-              <a:t>07-Mar-25</a:t>
+              <a:t>09-Mar-25</a:t>
             </a:fld>
             <a:endParaRPr lang="en-US"/>
           </a:p>
@@ -8275,7 +8275,7 @@
           <a:p>
             <a:fld id="{1C517A45-943C-42E3-AA2A-6F37792D039D}" type="datetimeFigureOut">
               <a:rPr lang="en-US" smtClean="0"/>
-              <a:t>07-Mar-25</a:t>
+              <a:t>09-Mar-25</a:t>
             </a:fld>
             <a:endParaRPr lang="en-US"/>
           </a:p>
@@ -8480,7 +8480,7 @@
           <a:p>
             <a:fld id="{1C517A45-943C-42E3-AA2A-6F37792D039D}" type="datetimeFigureOut">
               <a:rPr lang="en-US" smtClean="0"/>
-              <a:t>07-Mar-25</a:t>
+              <a:t>09-Mar-25</a:t>
             </a:fld>
             <a:endParaRPr lang="en-US"/>
           </a:p>
@@ -8657,7 +8657,7 @@
           <a:p>
             <a:fld id="{1C517A45-943C-42E3-AA2A-6F37792D039D}" type="datetimeFigureOut">
               <a:rPr lang="en-US" smtClean="0"/>
-              <a:t>07-Mar-25</a:t>
+              <a:t>09-Mar-25</a:t>
             </a:fld>
             <a:endParaRPr lang="en-US"/>
           </a:p>
@@ -8990,7 +8990,7 @@
           <a:p>
             <a:fld id="{1C517A45-943C-42E3-AA2A-6F37792D039D}" type="datetimeFigureOut">
               <a:rPr lang="en-US" smtClean="0"/>
-              <a:t>07-Mar-25</a:t>
+              <a:t>09-Mar-25</a:t>
             </a:fld>
             <a:endParaRPr lang="en-US"/>
           </a:p>
@@ -9335,7 +9335,7 @@
           <a:p>
             <a:fld id="{1C517A45-943C-42E3-AA2A-6F37792D039D}" type="datetimeFigureOut">
               <a:rPr lang="en-US" smtClean="0"/>
-              <a:t>07-Mar-25</a:t>
+              <a:t>09-Mar-25</a:t>
             </a:fld>
             <a:endParaRPr lang="en-US"/>
           </a:p>
@@ -11452,7 +11452,7 @@
           <a:p>
             <a:fld id="{1C517A45-943C-42E3-AA2A-6F37792D039D}" type="datetimeFigureOut">
               <a:rPr lang="en-US" smtClean="0"/>
-              <a:t>07-Mar-25</a:t>
+              <a:t>09-Mar-25</a:t>
             </a:fld>
             <a:endParaRPr lang="en-US"/>
           </a:p>
@@ -13312,6 +13312,7 @@
             </a:r>
           </a:p>
           <a:p>
+            <a:pPr algn="just"/>
             <a:r>
               <a:rPr lang="en-US" dirty="0">
                 <a:latin typeface="Calibri" panose="020F0502020204030204" pitchFamily="34" charset="0"/>
@@ -13336,12 +13337,13 @@
             </a:r>
           </a:p>
           <a:p>
+            <a:pPr algn="just"/>
             <a:r>
               <a:rPr lang="en-US" dirty="0">
                 <a:latin typeface="Calibri" panose="020F0502020204030204" pitchFamily="34" charset="0"/>
                 <a:cs typeface="Calibri" panose="020F0502020204030204" pitchFamily="34" charset="0"/>
               </a:rPr>
-              <a:t>ROI can be measured by the number of phishing attacks prevented, the reduction in data breaches, and the decrease in manual intervention required to address threats. Organizations can also track the reduction in customer complaints or incidents related to phishing, as well as the potential savings from preventing major security incidents.</a:t>
+              <a:t>Return on Investment (ROI) can be measured by the number of phishing attacks prevented, the reduction in data breaches, and the decrease in manual intervention required to address threats. Organizations can also track the reduction in customer complaints or incidents related to phishing, as well as the potential savings from preventing major security incidents.</a:t>
             </a:r>
           </a:p>
           <a:p>

</xml_diff>